<commit_message>
figures: synchronize Figure 7 simulated CBDir-gene scores
</commit_message>
<xml_diff>
--- a/figures/assembly/fig7/fig7.pptx
+++ b/figures/assembly/fig7/fig7.pptx
@@ -1228,13 +1228,13 @@
                 <c:formatCode>General</c:formatCode>
                 <c:ptCount val="20"/>
                 <c:pt idx="12" c:formatCode="0.0000">
-                  <c:v>0.9616437570186175</c:v>
+                  <c:v>0.961643757018617</c:v>
                 </c:pt>
                 <c:pt idx="14" c:formatCode="0.0000">
-                  <c:v>0.8596805263336675</c:v>
+                  <c:v>0.859680526333668</c:v>
                 </c:pt>
                 <c:pt idx="15" c:formatCode="0.0000">
-                  <c:v>1.0632843444677784</c:v>
+                  <c:v>1.06328434446778</c:v>
                 </c:pt>
               </c:numCache>
             </c:numRef>
@@ -5349,31 +5349,31 @@
                 <c:formatCode>General</c:formatCode>
                 <c:ptCount val="20"/>
                 <c:pt idx="2" c:formatCode="0.0000">
-                  <c:v>1.4615</c:v>
+                  <c:v>1.4618</c:v>
                 </c:pt>
                 <c:pt idx="3" c:formatCode="0.0000">
-                  <c:v>1.5641</c:v>
+                  <c:v>1.564</c:v>
                 </c:pt>
                 <c:pt idx="4" c:formatCode="0.0000">
-                  <c:v>1.2686</c:v>
+                  <c:v>1.2751</c:v>
                 </c:pt>
                 <c:pt idx="7" c:formatCode="0.0000">
-                  <c:v>1.0112</c:v>
+                  <c:v>1.0141</c:v>
                 </c:pt>
                 <c:pt idx="11" c:formatCode="0.0000">
-                  <c:v>1.0119</c:v>
+                  <c:v>1.016</c:v>
                 </c:pt>
                 <c:pt idx="14" c:formatCode="0.0000">
-                  <c:v>1.5158</c:v>
+                  <c:v>1.5156</c:v>
                 </c:pt>
                 <c:pt idx="15" c:formatCode="0.0000">
-                  <c:v>1.1958</c:v>
+                  <c:v>1.1943</c:v>
                 </c:pt>
                 <c:pt idx="17" c:formatCode="0.0000">
-                  <c:v>1.4695</c:v>
+                  <c:v>1.4694</c:v>
                 </c:pt>
                 <c:pt idx="18" c:formatCode="0.0000">
-                  <c:v>1.5197</c:v>
+                  <c:v>1.5211</c:v>
                 </c:pt>
               </c:numCache>
             </c:numRef>
@@ -6368,16 +6368,16 @@
                 <c:formatCode>General</c:formatCode>
                 <c:ptCount val="20"/>
                 <c:pt idx="6" c:formatCode="0.0000">
-                  <c:v>1.6443091561579468</c:v>
+                  <c:v>1.64430915615795</c:v>
                 </c:pt>
                 <c:pt idx="13" c:formatCode="0.0000">
                   <c:v>1.49267118761886</c:v>
                 </c:pt>
                 <c:pt idx="14" c:formatCode="0.0000">
-                  <c:v>0.9836105844466401</c:v>
+                  <c:v>0.98361058444664</c:v>
                 </c:pt>
                 <c:pt idx="15" c:formatCode="0.0000">
-                  <c:v>1.3150070141443386</c:v>
+                  <c:v>1.31500701414434</c:v>
                 </c:pt>
               </c:numCache>
             </c:numRef>
@@ -9889,10 +9889,10 @@
                         <a:buNone/>
                       </a:pPr>
                       <a:r>
-                        <a:rPr lang="en-US" altLang="zh-CN" sz="400"/>
+                        <a:rPr lang="en-US" altLang="zh-CN" sz="500"/>
                         <a:t>Methods</a:t>
                       </a:r>
-                      <a:endParaRPr lang="en-US" altLang="zh-CN" sz="400"/>
+                      <a:endParaRPr lang="en-US" altLang="zh-CN" sz="500"/>
                     </a:p>
                   </a:txBody>
                   <a:tcPr marL="36195" marR="36195" marT="36195" marB="36195" anchor="ctr" anchorCtr="0">
@@ -9939,10 +9939,10 @@
                         <a:buNone/>
                       </a:pPr>
                       <a:r>
-                        <a:rPr lang="en-US" altLang="zh-CN" sz="400"/>
+                        <a:rPr lang="en-US" altLang="zh-CN" sz="500"/>
                         <a:t>Core Algorithm/Model</a:t>
                       </a:r>
-                      <a:endParaRPr lang="en-US" altLang="zh-CN" sz="400"/>
+                      <a:endParaRPr lang="en-US" altLang="zh-CN" sz="500"/>
                     </a:p>
                   </a:txBody>
                   <a:tcPr marL="36195" marR="36195" marT="36195" marB="36195" anchor="ctr" anchorCtr="0">
@@ -9989,10 +9989,10 @@
                         <a:buNone/>
                       </a:pPr>
                       <a:r>
-                        <a:rPr lang="en-US" altLang="zh-CN" sz="400"/>
+                        <a:rPr lang="en-US" altLang="zh-CN" sz="500"/>
                         <a:t>How to estimate kinetic parameters</a:t>
                       </a:r>
-                      <a:endParaRPr lang="en-US" altLang="zh-CN" sz="400"/>
+                      <a:endParaRPr lang="en-US" altLang="zh-CN" sz="500"/>
                     </a:p>
                   </a:txBody>
                   <a:tcPr marL="36195" marR="36195" marT="36195" marB="36195" anchor="ctr" anchorCtr="0">
@@ -10061,10 +10061,10 @@
                         <a:buNone/>
                       </a:pPr>
                       <a:r>
-                        <a:rPr lang="en-US" altLang="zh-CN" sz="400"/>
+                        <a:rPr lang="en-US" altLang="zh-CN" sz="500"/>
                         <a:t>Whether to calculate and output du/dt</a:t>
                       </a:r>
-                      <a:endParaRPr lang="en-US" altLang="zh-CN" sz="400"/>
+                      <a:endParaRPr lang="en-US" altLang="zh-CN" sz="500"/>
                     </a:p>
                   </a:txBody>
                   <a:tcPr marL="36195" marR="36195" marT="36195" marB="36195" anchor="ctr" anchorCtr="0">
@@ -10111,10 +10111,10 @@
                         <a:buNone/>
                       </a:pPr>
                       <a:r>
-                        <a:rPr lang="en-US" altLang="zh-CN" sz="400"/>
+                        <a:rPr lang="en-US" altLang="zh-CN" sz="500"/>
                         <a:t>Performance at Cell level</a:t>
                       </a:r>
-                      <a:endParaRPr lang="en-US" altLang="zh-CN" sz="400"/>
+                      <a:endParaRPr lang="en-US" altLang="zh-CN" sz="500"/>
                     </a:p>
                   </a:txBody>
                   <a:tcPr marL="36195" marR="36195" marT="36195" marB="36195" anchor="ctr" anchorCtr="0">
@@ -10231,10 +10231,10 @@
                         <a:buNone/>
                       </a:pPr>
                       <a:r>
-                        <a:rPr lang="en-US" altLang="zh-CN" sz="400"/>
+                        <a:rPr lang="en-US" altLang="zh-CN" sz="500"/>
                         <a:t>Performance at Gene level</a:t>
                       </a:r>
-                      <a:endParaRPr lang="en-US" altLang="zh-CN" sz="400"/>
+                      <a:endParaRPr lang="en-US" altLang="zh-CN" sz="500"/>
                     </a:p>
                   </a:txBody>
                   <a:tcPr marL="36195" marR="36195" marT="36195" marB="36195" anchor="ctr" anchorCtr="0">
@@ -10391,10 +10391,10 @@
                         <a:buNone/>
                       </a:pPr>
                       <a:r>
-                        <a:rPr lang="en-US" altLang="zh-CN" sz="400"/>
+                        <a:rPr lang="en-US" altLang="zh-CN" sz="500"/>
                         <a:t>α</a:t>
                       </a:r>
-                      <a:endParaRPr lang="en-US" altLang="zh-CN" sz="400"/>
+                      <a:endParaRPr lang="en-US" altLang="zh-CN" sz="500"/>
                     </a:p>
                   </a:txBody>
                   <a:tcPr marL="36195" marR="36195" marT="36195" marB="36195" anchor="ctr" anchorCtr="0">
@@ -10438,18 +10438,18 @@
                         <a:buNone/>
                       </a:pPr>
                       <a:r>
-                        <a:rPr lang="en-US" altLang="zh-CN" sz="400"/>
+                        <a:rPr lang="en-US" altLang="zh-CN" sz="500"/>
                         <a:t>β</a:t>
                       </a:r>
                       <a:r>
-                        <a:rPr lang="zh-CN" altLang="en-US" sz="400"/>
+                        <a:rPr lang="zh-CN" altLang="en-US" sz="500"/>
                         <a:t>＆</a:t>
                       </a:r>
                       <a:r>
-                        <a:rPr lang="en-US" altLang="zh-CN" sz="400"/>
+                        <a:rPr lang="en-US" altLang="zh-CN" sz="500"/>
                         <a:t>γ</a:t>
                       </a:r>
-                      <a:endParaRPr lang="en-US" altLang="zh-CN" sz="400"/>
+                      <a:endParaRPr lang="en-US" altLang="zh-CN" sz="500"/>
                     </a:p>
                   </a:txBody>
                   <a:tcPr marL="36195" marR="36195" marT="36195" marB="36195" anchor="ctr" anchorCtr="0">
@@ -10509,10 +10509,10 @@
                         <a:buNone/>
                       </a:pPr>
                       <a:r>
-                        <a:rPr lang="en-US" altLang="zh-CN" sz="400"/>
+                        <a:rPr lang="en-US" altLang="zh-CN" sz="500"/>
                         <a:t>Local</a:t>
                       </a:r>
-                      <a:endParaRPr lang="en-US" altLang="zh-CN" sz="400"/>
+                      <a:endParaRPr lang="en-US" altLang="zh-CN" sz="500"/>
                     </a:p>
                   </a:txBody>
                   <a:tcPr marL="36195" marR="36195" marT="36195" marB="36195" anchor="ctr" anchorCtr="0">
@@ -10590,10 +10590,10 @@
                         <a:buNone/>
                       </a:pPr>
                       <a:r>
-                        <a:rPr lang="en-US" altLang="zh-CN" sz="400"/>
+                        <a:rPr lang="en-US" altLang="zh-CN" sz="500"/>
                         <a:t>Global</a:t>
                       </a:r>
-                      <a:endParaRPr lang="en-US" altLang="zh-CN" sz="400"/>
+                      <a:endParaRPr lang="en-US" altLang="zh-CN" sz="500"/>
                     </a:p>
                   </a:txBody>
                   <a:tcPr marL="36195" marR="36195" marT="36195" marB="36195" anchor="ctr" anchorCtr="0">
@@ -10708,10 +10708,10 @@
                         <a:buNone/>
                       </a:pPr>
                       <a:r>
-                        <a:rPr lang="en-US" altLang="zh-CN" sz="400"/>
+                        <a:rPr lang="en-US" altLang="zh-CN" sz="500"/>
                         <a:t>Gene-level kinetics</a:t>
                       </a:r>
-                      <a:endParaRPr lang="en-US" altLang="zh-CN" sz="400"/>
+                      <a:endParaRPr lang="en-US" altLang="zh-CN" sz="500"/>
                     </a:p>
                   </a:txBody>
                   <a:tcPr marL="36195" marR="36195" marT="36195" marB="36195" anchor="ctr" anchorCtr="0">
@@ -10826,12 +10826,14 @@
                         <a:buNone/>
                       </a:pPr>
                       <a:r>
-                        <a:rPr lang="en-US" altLang="zh-CN" sz="400">
+                        <a:rPr lang="en-US" altLang="zh-CN" sz="500">
                           <a:sym typeface="Arial" panose="020B0604020202090204" pitchFamily="34" charset="0"/>
                         </a:rPr>
                         <a:t>Kinetic parameters</a:t>
                       </a:r>
-                      <a:endParaRPr lang="en-US" altLang="zh-CN" sz="400"/>
+                      <a:endParaRPr lang="en-US" altLang="zh-CN" sz="500">
+                        <a:sym typeface="Arial" panose="020B0604020202090204" pitchFamily="34" charset="0"/>
+                      </a:endParaRPr>
                     </a:p>
                   </a:txBody>
                   <a:tcPr marL="36195" marR="36195" marT="36195" marB="36195" anchor="ctr" anchorCtr="0">
@@ -11535,10 +11537,10 @@
                         <a:buNone/>
                       </a:pPr>
                       <a:r>
-                        <a:rPr lang="en-US" altLang="zh-CN" sz="400"/>
-                        <a:t>scVelo_deterministic</a:t>
+                        <a:rPr lang="en-US" altLang="zh-CN" sz="500"/>
+                        <a:t>scVelo_det</a:t>
                       </a:r>
-                      <a:endParaRPr lang="en-US"/>
+                      <a:endParaRPr lang="en-US" altLang="zh-CN" sz="500"/>
                     </a:p>
                   </a:txBody>
                   <a:tcPr marL="36195" marR="36195" marT="36195" marB="36195" anchor="ctr" anchorCtr="0">
@@ -12213,10 +12215,10 @@
                         <a:buNone/>
                       </a:pPr>
                       <a:r>
-                        <a:rPr lang="en-US" altLang="zh-CN" sz="400"/>
-                        <a:t>scVelo_stochastic</a:t>
+                        <a:rPr lang="en-US" altLang="zh-CN" sz="500"/>
+                        <a:t>scVelo_sto</a:t>
                       </a:r>
-                      <a:endParaRPr lang="en-US"/>
+                      <a:endParaRPr lang="en-US" altLang="zh-CN" sz="500"/>
                     </a:p>
                   </a:txBody>
                   <a:tcPr marL="36195" marR="36195" marT="36195" marB="36195" anchor="ctr" anchorCtr="0">
@@ -12893,10 +12895,10 @@
                         <a:buNone/>
                       </a:pPr>
                       <a:r>
-                        <a:rPr lang="en-US" altLang="zh-CN" sz="400"/>
-                        <a:t>scVelo_dynamic</a:t>
+                        <a:rPr lang="en-US" altLang="zh-CN" sz="500"/>
+                        <a:t>scVelo_dyn</a:t>
                       </a:r>
-                      <a:endParaRPr lang="en-US"/>
+                      <a:endParaRPr lang="en-US" altLang="zh-CN" sz="500"/>
                     </a:p>
                   </a:txBody>
                   <a:tcPr marL="36195" marR="36195" marT="36195" marB="36195" anchor="ctr" anchorCtr="0">
@@ -13581,10 +13583,10 @@
                         <a:buNone/>
                       </a:pPr>
                       <a:r>
-                        <a:rPr lang="en-US" altLang="zh-CN" sz="400"/>
+                        <a:rPr lang="en-US" altLang="zh-CN" sz="500"/>
                         <a:t>MultiVelo (RNA_only)</a:t>
                       </a:r>
-                      <a:endParaRPr lang="en-US"/>
+                      <a:endParaRPr lang="en-US" altLang="zh-CN" sz="500"/>
                     </a:p>
                   </a:txBody>
                   <a:tcPr marL="36195" marR="36195" marT="36195" marB="36195" anchor="ctr" anchorCtr="0">
@@ -14269,10 +14271,10 @@
                         <a:buNone/>
                       </a:pPr>
                       <a:r>
-                        <a:rPr lang="en-US" altLang="zh-CN" sz="400"/>
+                        <a:rPr lang="en-US" altLang="zh-CN" sz="500"/>
                         <a:t>UniTVelo</a:t>
                       </a:r>
-                      <a:endParaRPr lang="en-US"/>
+                      <a:endParaRPr lang="en-US" altLang="zh-CN" sz="500"/>
                     </a:p>
                   </a:txBody>
                   <a:tcPr marL="36195" marR="36195" marT="36195" marB="36195" anchor="ctr" anchorCtr="0">
@@ -14947,10 +14949,20 @@
                         <a:buNone/>
                       </a:pPr>
                       <a:r>
-                        <a:rPr lang="en-US" altLang="zh-CN" sz="400"/>
-                        <a:t>UniTVelo(mode2)</a:t>
+                        <a:rPr lang="en-US" altLang="zh-CN" sz="500"/>
+                        <a:t>UniTVelo</a:t>
                       </a:r>
-                      <a:endParaRPr lang="en-US"/>
+                      <a:endParaRPr lang="en-US" altLang="zh-CN" sz="500"/>
+                    </a:p>
+                    <a:p>
+                      <a:pPr algn="ctr">
+                        <a:buNone/>
+                      </a:pPr>
+                      <a:r>
+                        <a:rPr lang="en-US" altLang="zh-CN" sz="500"/>
+                        <a:t>(mode2)</a:t>
+                      </a:r>
+                      <a:endParaRPr lang="en-US" altLang="zh-CN" sz="500"/>
                     </a:p>
                   </a:txBody>
                   <a:tcPr marL="36195" marR="36195" marT="36195" marB="36195" anchor="ctr" anchorCtr="0">
@@ -15637,10 +15649,10 @@
                         <a:buNone/>
                       </a:pPr>
                       <a:r>
-                        <a:rPr lang="en-US" altLang="zh-CN" sz="400"/>
+                        <a:rPr lang="en-US" altLang="zh-CN" sz="500"/>
                         <a:t>Dynamo</a:t>
                       </a:r>
-                      <a:endParaRPr lang="en-US"/>
+                      <a:endParaRPr lang="en-US" altLang="zh-CN" sz="500"/>
                     </a:p>
                   </a:txBody>
                   <a:tcPr marL="36195" marR="36195" marT="36195" marB="36195" anchor="ctr" anchorCtr="0">
@@ -16339,10 +16351,10 @@
                         <a:buNone/>
                       </a:pPr>
                       <a:r>
-                        <a:rPr lang="en-US" altLang="zh-CN" sz="400"/>
+                        <a:rPr lang="en-US" altLang="zh-CN" sz="500"/>
                         <a:t>TIvelo</a:t>
                       </a:r>
-                      <a:endParaRPr lang="en-US"/>
+                      <a:endParaRPr lang="en-US" altLang="zh-CN" sz="500"/>
                     </a:p>
                   </a:txBody>
                   <a:tcPr marL="36195" marR="36195" marT="36195" marB="36195" anchor="ctr" anchorCtr="0">
@@ -17019,10 +17031,10 @@
                         <a:buNone/>
                       </a:pPr>
                       <a:r>
-                        <a:rPr lang="en-US" altLang="zh-CN" sz="400"/>
+                        <a:rPr lang="en-US" altLang="zh-CN" sz="500"/>
                         <a:t>cell2fate</a:t>
                       </a:r>
-                      <a:endParaRPr lang="en-US"/>
+                      <a:endParaRPr lang="en-US" altLang="zh-CN" sz="500"/>
                     </a:p>
                   </a:txBody>
                   <a:tcPr marL="36195" marR="36195" marT="36195" marB="36195" anchor="ctr" anchorCtr="0">
@@ -17700,10 +17712,10 @@
                         <a:buNone/>
                       </a:pPr>
                       <a:r>
-                        <a:rPr lang="en-US" altLang="zh-CN" sz="400"/>
+                        <a:rPr lang="en-US" altLang="zh-CN" sz="500"/>
                         <a:t>TFvelo</a:t>
                       </a:r>
-                      <a:endParaRPr lang="en-US"/>
+                      <a:endParaRPr lang="en-US" altLang="zh-CN" sz="500"/>
                     </a:p>
                   </a:txBody>
                   <a:tcPr marL="36195" marR="36195" marT="36195" marB="36195" anchor="ctr" anchorCtr="0">
@@ -18383,10 +18395,10 @@
                         <a:buNone/>
                       </a:pPr>
                       <a:r>
-                        <a:rPr lang="en-US" altLang="zh-CN" sz="400"/>
+                        <a:rPr lang="en-US" altLang="zh-CN" sz="500"/>
                         <a:t>veloAE</a:t>
                       </a:r>
-                      <a:endParaRPr lang="en-US"/>
+                      <a:endParaRPr lang="en-US" altLang="zh-CN" sz="500"/>
                     </a:p>
                   </a:txBody>
                   <a:tcPr marL="36195" marR="36195" marT="36195" marB="36195" anchor="ctr" anchorCtr="0">
@@ -19075,10 +19087,10 @@
                         <a:buNone/>
                       </a:pPr>
                       <a:r>
-                        <a:rPr lang="en-US" altLang="zh-CN" sz="400"/>
+                        <a:rPr lang="en-US" altLang="zh-CN" sz="500"/>
                         <a:t>veloVI</a:t>
                       </a:r>
-                      <a:endParaRPr lang="en-US"/>
+                      <a:endParaRPr lang="en-US" altLang="zh-CN" sz="500"/>
                     </a:p>
                   </a:txBody>
                   <a:tcPr marL="36195" marR="36195" marT="36195" marB="36195" anchor="ctr" anchorCtr="0">
@@ -19753,10 +19765,10 @@
                         <a:buNone/>
                       </a:pPr>
                       <a:r>
-                        <a:rPr lang="en-US" altLang="zh-CN" sz="400"/>
+                        <a:rPr lang="en-US" altLang="zh-CN" sz="500"/>
                         <a:t>DeepKINET</a:t>
                       </a:r>
-                      <a:endParaRPr lang="en-US"/>
+                      <a:endParaRPr lang="en-US" altLang="zh-CN" sz="500"/>
                     </a:p>
                   </a:txBody>
                   <a:tcPr marL="36195" marR="36195" marT="36195" marB="36195" anchor="ctr" anchorCtr="0">
@@ -20460,10 +20472,10 @@
                         <a:buNone/>
                       </a:pPr>
                       <a:r>
-                        <a:rPr lang="en-US" altLang="zh-CN" sz="400"/>
+                        <a:rPr lang="en-US" altLang="zh-CN" sz="500"/>
                         <a:t>TSvelo</a:t>
                       </a:r>
-                      <a:endParaRPr lang="en-US"/>
+                      <a:endParaRPr lang="en-US" altLang="zh-CN" sz="500"/>
                     </a:p>
                   </a:txBody>
                   <a:tcPr marL="36195" marR="36195" marT="36195" marB="36195" anchor="ctr" anchorCtr="0">
@@ -21165,10 +21177,10 @@
                         <a:buNone/>
                       </a:pPr>
                       <a:r>
-                        <a:rPr lang="en-US" altLang="zh-CN" sz="400"/>
+                        <a:rPr lang="en-US" altLang="zh-CN" sz="500"/>
                         <a:t>cellDancer</a:t>
                       </a:r>
-                      <a:endParaRPr lang="en-US"/>
+                      <a:endParaRPr lang="en-US" altLang="zh-CN" sz="500"/>
                     </a:p>
                   </a:txBody>
                   <a:tcPr marL="36195" marR="36195" marT="36195" marB="36195" anchor="ctr" anchorCtr="0">
@@ -21863,10 +21875,10 @@
                         <a:buNone/>
                       </a:pPr>
                       <a:r>
-                        <a:rPr lang="en-US" altLang="zh-CN" sz="400"/>
+                        <a:rPr lang="en-US" altLang="zh-CN" sz="500"/>
                         <a:t>DeepVelo</a:t>
                       </a:r>
-                      <a:endParaRPr lang="en-US"/>
+                      <a:endParaRPr lang="en-US" altLang="zh-CN" sz="500"/>
                     </a:p>
                   </a:txBody>
                   <a:tcPr marL="36195" marR="36195" marT="36195" marB="36195" anchor="ctr" anchorCtr="0">
@@ -22567,10 +22579,10 @@
                         <a:buNone/>
                       </a:pPr>
                       <a:r>
-                        <a:rPr lang="en-US" altLang="zh-CN" sz="400"/>
+                        <a:rPr lang="en-US" altLang="zh-CN" sz="500"/>
                         <a:t>SDEvelo</a:t>
                       </a:r>
-                      <a:endParaRPr lang="en-US"/>
+                      <a:endParaRPr lang="en-US" altLang="zh-CN" sz="500"/>
                     </a:p>
                   </a:txBody>
                   <a:tcPr marL="36195" marR="36195" marT="36195" marB="36195" anchor="ctr" anchorCtr="0">
@@ -23248,10 +23260,10 @@
                         <a:buNone/>
                       </a:pPr>
                       <a:r>
-                        <a:rPr lang="en-US" altLang="zh-CN" sz="400"/>
+                        <a:rPr lang="en-US" altLang="zh-CN" sz="500"/>
                         <a:t>DeepVelo_scv</a:t>
                       </a:r>
-                      <a:endParaRPr lang="en-US"/>
+                      <a:endParaRPr lang="en-US" altLang="zh-CN" sz="500"/>
                     </a:p>
                   </a:txBody>
                   <a:tcPr marL="36195" marR="36195" marT="36195" marB="36195" anchor="ctr" anchorCtr="0">
@@ -23923,10 +23935,10 @@
                         <a:buNone/>
                       </a:pPr>
                       <a:r>
-                        <a:rPr lang="en-US" altLang="zh-CN" sz="400"/>
+                        <a:rPr lang="en-US" altLang="zh-CN" sz="500"/>
                         <a:t>GraphVelo_scv</a:t>
                       </a:r>
-                      <a:endParaRPr lang="en-US"/>
+                      <a:endParaRPr lang="en-US" altLang="zh-CN" sz="500"/>
                     </a:p>
                   </a:txBody>
                   <a:tcPr marL="36195" marR="36195" marT="36195" marB="36195" anchor="ctr" anchorCtr="0">
@@ -24598,10 +24610,10 @@
                         <a:buNone/>
                       </a:pPr>
                       <a:r>
-                        <a:rPr lang="en-US" altLang="zh-CN" sz="400"/>
+                        <a:rPr lang="en-US" altLang="zh-CN" sz="500"/>
                         <a:t>GraphVelo_dyn</a:t>
                       </a:r>
-                      <a:endParaRPr lang="en-US"/>
+                      <a:endParaRPr lang="en-US" altLang="zh-CN" sz="500"/>
                     </a:p>
                   </a:txBody>
                   <a:tcPr marL="36195" marR="36195" marT="36195" marB="36195" anchor="ctr" anchorCtr="0">

</xml_diff>

<commit_message>
Align Forebrain evaluation frames and refresh paper assets
Use shared PCA30 for Forebrain Cell CBDir and frozen UMAP2 for BATC. Refresh compact results, rankings, streamline previews, editable figure sources and final exports. Update static website bindings and include Ensemble changes in Pages deployment triggers.
</commit_message>
<xml_diff>
--- a/figures/assembly/fig7/fig7.pptx
+++ b/figures/assembly/fig7/fig7.pptx
@@ -1723,64 +1723,64 @@
                   <c:formatCode>General</c:formatCode>
                   <c:ptCount val="20"/>
                   <c:pt idx="0">
-                    <c:v>0.326656504195493</c:v>
+                    <c:v>0.3262397689702917</c:v>
                   </c:pt>
                   <c:pt idx="1">
-                    <c:v>0.344208822721661</c:v>
+                    <c:v>0.3435703450453553</c:v>
                   </c:pt>
                   <c:pt idx="2">
-                    <c:v>0.342706305567108</c:v>
+                    <c:v>0.3436244644578891</c:v>
                   </c:pt>
                   <c:pt idx="3">
-                    <c:v>0.346735590397112</c:v>
+                    <c:v>0.34582227411271066</c:v>
                   </c:pt>
                   <c:pt idx="4">
-                    <c:v>0.467144166244782</c:v>
+                    <c:v>0.43157138879268925</c:v>
                   </c:pt>
                   <c:pt idx="5">
-                    <c:v>0.330392827205629</c:v>
+                    <c:v>0.3309866919833117</c:v>
                   </c:pt>
                   <c:pt idx="6">
-                    <c:v>0.324944926568854</c:v>
+                    <c:v>0.32632521056472474</c:v>
                   </c:pt>
                   <c:pt idx="7">
-                    <c:v>0.288437206798049</c:v>
+                    <c:v>0.29085687481685596</c:v>
                   </c:pt>
                   <c:pt idx="8">
-                    <c:v>0.336197554293652</c:v>
+                    <c:v>0.2940822578973262</c:v>
                   </c:pt>
                   <c:pt idx="9">
-                    <c:v>0.404677499943073</c:v>
+                    <c:v>0.39010301924109336</c:v>
                   </c:pt>
                   <c:pt idx="10">
-                    <c:v>0.410577169817523</c:v>
+                    <c:v>0.40975400675619467</c:v>
                   </c:pt>
                   <c:pt idx="11">
-                    <c:v>0.297192729466325</c:v>
+                    <c:v>0.30059988324352976</c:v>
                   </c:pt>
                   <c:pt idx="12">
-                    <c:v>0.261921462461915</c:v>
+                    <c:v>0.25955327583883386</c:v>
                   </c:pt>
                   <c:pt idx="13">
-                    <c:v>0.391349882230042</c:v>
+                    <c:v>0.378646088429091</c:v>
                   </c:pt>
                   <c:pt idx="14">
-                    <c:v>0.331230659545362</c:v>
+                    <c:v>0.3318531604652658</c:v>
                   </c:pt>
                   <c:pt idx="15">
-                    <c:v>0.368612524179767</c:v>
+                    <c:v>0.37207488955157597</c:v>
                   </c:pt>
                   <c:pt idx="16">
-                    <c:v>0.278332126957989</c:v>
+                    <c:v>0.2708974299371506</c:v>
                   </c:pt>
                   <c:pt idx="17">
-                    <c:v>0.362895076341102</c:v>
+                    <c:v>0.36355639668843864</c:v>
                   </c:pt>
                   <c:pt idx="18">
-                    <c:v>0.226365357238012</c:v>
+                    <c:v>0.22221700556093338</c:v>
                   </c:pt>
                   <c:pt idx="19">
-                    <c:v>0.377518372403849</c:v>
+                    <c:v>0.37822113188892065</c:v>
                   </c:pt>
                 </c:numCache>
               </c:numRef>
@@ -1792,64 +1792,64 @@
                   <c:formatCode>General</c:formatCode>
                   <c:ptCount val="20"/>
                   <c:pt idx="0">
-                    <c:v>0.326656504195493</c:v>
+                    <c:v>0.3262397689702917</c:v>
                   </c:pt>
                   <c:pt idx="1">
-                    <c:v>0.344208822721661</c:v>
+                    <c:v>0.3435703450453553</c:v>
                   </c:pt>
                   <c:pt idx="2">
-                    <c:v>0.342706305567108</c:v>
+                    <c:v>0.3436244644578891</c:v>
                   </c:pt>
                   <c:pt idx="3">
-                    <c:v>0.346735590397112</c:v>
+                    <c:v>0.34582227411271066</c:v>
                   </c:pt>
                   <c:pt idx="4">
-                    <c:v>0.467144166244782</c:v>
+                    <c:v>0.43157138879268925</c:v>
                   </c:pt>
                   <c:pt idx="5">
-                    <c:v>0.330392827205629</c:v>
+                    <c:v>0.3309866919833117</c:v>
                   </c:pt>
                   <c:pt idx="6">
-                    <c:v>0.324944926568854</c:v>
+                    <c:v>0.32632521056472474</c:v>
                   </c:pt>
                   <c:pt idx="7">
-                    <c:v>0.288437206798049</c:v>
+                    <c:v>0.29085687481685596</c:v>
                   </c:pt>
                   <c:pt idx="8">
-                    <c:v>0.336197554293652</c:v>
+                    <c:v>0.2940822578973262</c:v>
                   </c:pt>
                   <c:pt idx="9">
-                    <c:v>0.404677499943073</c:v>
+                    <c:v>0.39010301924109336</c:v>
                   </c:pt>
                   <c:pt idx="10">
-                    <c:v>0.410577169817523</c:v>
+                    <c:v>0.40975400675619467</c:v>
                   </c:pt>
                   <c:pt idx="11">
-                    <c:v>0.297192729466325</c:v>
+                    <c:v>0.30059988324352976</c:v>
                   </c:pt>
                   <c:pt idx="12">
-                    <c:v>0.261921462461915</c:v>
+                    <c:v>0.25955327583883386</c:v>
                   </c:pt>
                   <c:pt idx="13">
-                    <c:v>0.391349882230042</c:v>
+                    <c:v>0.378646088429091</c:v>
                   </c:pt>
                   <c:pt idx="14">
-                    <c:v>0.331230659545362</c:v>
+                    <c:v>0.3318531604652658</c:v>
                   </c:pt>
                   <c:pt idx="15">
-                    <c:v>0.368612524179767</c:v>
+                    <c:v>0.37207488955157597</c:v>
                   </c:pt>
                   <c:pt idx="16">
-                    <c:v>0.278332126957989</c:v>
+                    <c:v>0.2708974299371506</c:v>
                   </c:pt>
                   <c:pt idx="17">
-                    <c:v>0.362895076341102</c:v>
+                    <c:v>0.36355639668843864</c:v>
                   </c:pt>
                   <c:pt idx="18">
-                    <c:v>0.226365357238012</c:v>
+                    <c:v>0.22221700556093338</c:v>
                   </c:pt>
                   <c:pt idx="19">
-                    <c:v>0.377518372403849</c:v>
+                    <c:v>0.37822113188892065</c:v>
                   </c:pt>
                 </c:numCache>
               </c:numRef>
@@ -1930,64 +1930,64 @@
                 <c:formatCode>General</c:formatCode>
                 <c:ptCount val="20"/>
                 <c:pt idx="0">
-                  <c:v>1.16402303493806</c:v>
+                  <c:v>1.157432863937669</c:v>
                 </c:pt>
                 <c:pt idx="1">
-                  <c:v>1.20165069262185</c:v>
+                  <c:v>1.1935131346861652</c:v>
                 </c:pt>
                 <c:pt idx="2">
-                  <c:v>1.11891089251312</c:v>
+                  <c:v>1.1164814012541207</c:v>
                 </c:pt>
                 <c:pt idx="3">
-                  <c:v>1.19205629301521</c:v>
+                  <c:v>1.1838365956128696</c:v>
                 </c:pt>
                 <c:pt idx="4">
-                  <c:v>1.18624234735833</c:v>
+                  <c:v>1.211050006520278</c:v>
                 </c:pt>
                 <c:pt idx="5">
-                  <c:v>1.2012208250689</c:v>
+                  <c:v>1.2002012513047917</c:v>
                 </c:pt>
                 <c:pt idx="6">
-                  <c:v>1.18678148800886</c:v>
+                  <c:v>1.1824811124786114</c:v>
                 </c:pt>
                 <c:pt idx="7">
-                  <c:v>1.30078674225361</c:v>
+                  <c:v>1.2971413337463495</c:v>
                 </c:pt>
                 <c:pt idx="8">
-                  <c:v>1.16090646619524</c:v>
+                  <c:v>1.1831837665130907</c:v>
                 </c:pt>
                 <c:pt idx="9">
-                  <c:v>1.12659491522866</c:v>
+                  <c:v>1.1064223659105266</c:v>
                 </c:pt>
                 <c:pt idx="10">
-                  <c:v>1.11041743218309</c:v>
+                  <c:v>1.1030452898998937</c:v>
                 </c:pt>
                 <c:pt idx="11">
-                  <c:v>1.28179015428112</c:v>
+                  <c:v>1.276325197230691</c:v>
                 </c:pt>
                 <c:pt idx="12">
-                  <c:v>1.15664115799592</c:v>
+                  <c:v>1.1459115777586275</c:v>
                 </c:pt>
                 <c:pt idx="13">
-                  <c:v>1.24031320060324</c:v>
+                  <c:v>1.2171606002722315</c:v>
                 </c:pt>
                 <c:pt idx="14">
-                  <c:v>1.13396258259776</c:v>
+                  <c:v>1.1301310914695164</c:v>
                 </c:pt>
                 <c:pt idx="15">
-                  <c:v>1.27183367710364</c:v>
+                  <c:v>1.2650989208683274</c:v>
                 </c:pt>
                 <c:pt idx="16">
-                  <c:v>1.11335346238829</c:v>
+                  <c:v>1.1004953465949892</c:v>
                 </c:pt>
                 <c:pt idx="17">
-                  <c:v>1.08604235130345</c:v>
+                  <c:v>1.0834746409675582</c:v>
                 </c:pt>
                 <c:pt idx="18">
-                  <c:v>1.28242124156078</c:v>
+                  <c:v>1.285179532086069</c:v>
                 </c:pt>
                 <c:pt idx="19">
-                  <c:v>1.1482283781436</c:v>
+                  <c:v>1.1446565698748643</c:v>
                 </c:pt>
               </c:numCache>
             </c:numRef>

</xml_diff>

<commit_message>
Restore veloVI scoring units and update benchmark results
Reverse veloVI additional per-axis min-max scaling for gene CBDir and simulated CosSim while retaining method-owned moments, fixed reference neighbors, canonical inputs, masks, and the other eight methods.

Refresh derived summaries, source-rendered panels, editable assemblies, author-exported PDFs, and public source/checksum mappings. Preserve gene identifiers in selected-edge plot tables.

Validation: 187 tests passed, 2 skipped; 13 PPT and PDF exports, 595 protected scientific assets, numerical change scope, equal-dataset/scenario aggregation, and all registered hashes verified.
</commit_message>
<xml_diff>
--- a/figures/assembly/fig7/fig7.pptx
+++ b/figures/assembly/fig7/fig7.pptx
@@ -4695,7 +4695,7 @@
                     <c:v>0.0544</c:v>
                   </c:pt>
                   <c:pt idx="11">
-                    <c:v>0.0866</c:v>
+                    <c:v>0.0573</c:v>
                   </c:pt>
                   <c:pt idx="14">
                     <c:v>0.0709</c:v>
@@ -4734,7 +4734,7 @@
                     <c:v>0.0544</c:v>
                   </c:pt>
                   <c:pt idx="11">
-                    <c:v>0.0866</c:v>
+                    <c:v>0.0573</c:v>
                   </c:pt>
                   <c:pt idx="14">
                     <c:v>0.0709</c:v>
@@ -4839,7 +4839,7 @@
                   <c:v>1.3353</c:v>
                 </c:pt>
                 <c:pt idx="11" c:formatCode="0.0000">
-                  <c:v>1.1106</c:v>
+                  <c:v>1.1032</c:v>
                 </c:pt>
                 <c:pt idx="14" c:formatCode="0.0000">
                   <c:v>1.0724</c:v>
@@ -5361,7 +5361,7 @@
                   <c:v>1.0141</c:v>
                 </c:pt>
                 <c:pt idx="11" c:formatCode="0.0000">
-                  <c:v>1.016</c:v>
+                  <c:v>1.0445</c:v>
                 </c:pt>
                 <c:pt idx="14" c:formatCode="0.0000">
                   <c:v>1.5156</c:v>
@@ -5883,7 +5883,7 @@
                   <c:v>0.9314</c:v>
                 </c:pt>
                 <c:pt idx="11" c:formatCode="0.0000">
-                  <c:v>1.0502</c:v>
+                  <c:v>1.0765</c:v>
                 </c:pt>
                 <c:pt idx="14" c:formatCode="0.0000">
                   <c:v>1.6726</c:v>

</xml_diff>

<commit_message>
Publish native velocity workflows, clean-state inputs and figure materials
</commit_message>
<xml_diff>
--- a/figures/assembly/fig7/fig7.pptx
+++ b/figures/assembly/fig7/fig7.pptx
@@ -505,7 +505,7 @@
                     <c:v>0.0917510573054259</c:v>
                   </c:pt>
                   <c:pt idx="3">
-                    <c:v>0.0530035717216372</c:v>
+                    <c:v>0.04315741996504089</c:v>
                   </c:pt>
                   <c:pt idx="4">
                     <c:v>0.0350603195543328</c:v>
@@ -574,7 +574,7 @@
                     <c:v>0.0917510573054259</c:v>
                   </c:pt>
                   <c:pt idx="3">
-                    <c:v>0.0530035717216372</c:v>
+                    <c:v>0.04315741996504089</c:v>
                   </c:pt>
                   <c:pt idx="4">
                     <c:v>0.0350603195543328</c:v>
@@ -712,7 +712,7 @@
                   <c:v>0.839491115015852</c:v>
                 </c:pt>
                 <c:pt idx="3">
-                  <c:v>0.843323751363103</c:v>
+                  <c:v>0.9140407495539863</c:v>
                 </c:pt>
                 <c:pt idx="4">
                   <c:v>0.942677232710325</c:v>
@@ -1732,7 +1732,7 @@
                     <c:v>0.3436244644578891</c:v>
                   </c:pt>
                   <c:pt idx="3">
-                    <c:v>0.34582227411271066</c:v>
+                    <c:v>0.43656448915947305</c:v>
                   </c:pt>
                   <c:pt idx="4">
                     <c:v>0.43157138879268925</c:v>
@@ -1801,7 +1801,7 @@
                     <c:v>0.3436244644578891</c:v>
                   </c:pt>
                   <c:pt idx="3">
-                    <c:v>0.34582227411271066</c:v>
+                    <c:v>0.43656448915947305</c:v>
                   </c:pt>
                   <c:pt idx="4">
                     <c:v>0.43157138879268925</c:v>
@@ -1939,7 +1939,7 @@
                   <c:v>1.1164814012541207</c:v>
                 </c:pt>
                 <c:pt idx="3">
-                  <c:v>1.1838365956128696</c:v>
+                  <c:v>1.0745786561637398</c:v>
                 </c:pt>
                 <c:pt idx="4">
                   <c:v>1.211050006520278</c:v>
@@ -2485,7 +2485,7 @@
                     <c:v>0.0758085655398101</c:v>
                   </c:pt>
                   <c:pt idx="3">
-                    <c:v>0.0472674055855019</c:v>
+                    <c:v>0.0404473235261983</c:v>
                   </c:pt>
                   <c:pt idx="4">
                     <c:v>0.0278675145016707</c:v>
@@ -2554,7 +2554,7 @@
                     <c:v>0.0758085655398101</c:v>
                   </c:pt>
                   <c:pt idx="3">
-                    <c:v>0.0472674055855019</c:v>
+                    <c:v>0.0404473235261983</c:v>
                   </c:pt>
                   <c:pt idx="4">
                     <c:v>0.0278675145016707</c:v>
@@ -2692,7 +2692,7 @@
                   <c:v>0.853129341147418</c:v>
                 </c:pt>
                 <c:pt idx="3">
-                  <c:v>0.865612180453154</c:v>
+                  <c:v>0.9233456480315738</c:v>
                 </c:pt>
                 <c:pt idx="4">
                   <c:v>0.956843768919953</c:v>
@@ -3238,7 +3238,7 @@
                     <c:v>0.0734311983370444</c:v>
                   </c:pt>
                   <c:pt idx="3">
-                    <c:v>0.051438804817275</c:v>
+                    <c:v>0.022804589681587085</c:v>
                   </c:pt>
                   <c:pt idx="4">
                     <c:v>0.118420793191644</c:v>
@@ -3307,7 +3307,7 @@
                     <c:v>0.0734311983370444</c:v>
                   </c:pt>
                   <c:pt idx="3">
-                    <c:v>0.051438804817275</c:v>
+                    <c:v>0.022804589681587085</c:v>
                   </c:pt>
                   <c:pt idx="4">
                     <c:v>0.118420793191644</c:v>
@@ -3445,7 +3445,7 @@
                   <c:v>1.152487047</c:v>
                 </c:pt>
                 <c:pt idx="3">
-                  <c:v>1.123387863</c:v>
+                  <c:v>1.0383690596458368</c:v>
                 </c:pt>
                 <c:pt idx="4">
                   <c:v>1.194962413</c:v>
@@ -3991,7 +3991,7 @@
                     <c:v>0.354377510464758</c:v>
                   </c:pt>
                   <c:pt idx="3">
-                    <c:v>0.320461639556236</c:v>
+                    <c:v>0.422702401012183</c:v>
                   </c:pt>
                   <c:pt idx="4">
                     <c:v>0.505491390992827</c:v>
@@ -4060,7 +4060,7 @@
                     <c:v>0.354377510464758</c:v>
                   </c:pt>
                   <c:pt idx="3">
-                    <c:v>0.320461639556236</c:v>
+                    <c:v>0.422702401012183</c:v>
                   </c:pt>
                   <c:pt idx="4">
                     <c:v>0.505491390992827</c:v>
@@ -4198,7 +4198,7 @@
                   <c:v>1.22779101866954</c:v>
                 </c:pt>
                 <c:pt idx="3">
-                  <c:v>1.30208722692857</c:v>
+                  <c:v>1.2414075588994724</c:v>
                 </c:pt>
                 <c:pt idx="4">
                   <c:v>1.34292929994119</c:v>
@@ -5871,31 +5871,31 @@
                 <c:formatCode>General</c:formatCode>
                 <c:ptCount val="20"/>
                 <c:pt idx="2" c:formatCode="0.0000">
-                  <c:v>1.6289</c:v>
+                  <c:v>1.6899</c:v>
                 </c:pt>
                 <c:pt idx="3" c:formatCode="0.0000">
-                  <c:v>1.7573</c:v>
+                  <c:v>1.8447</c:v>
                 </c:pt>
                 <c:pt idx="4" c:formatCode="0.0000">
-                  <c:v>1.3737</c:v>
+                  <c:v>1.3899</c:v>
                 </c:pt>
                 <c:pt idx="7" c:formatCode="0.0000">
-                  <c:v>0.9314</c:v>
+                  <c:v>0.9161</c:v>
                 </c:pt>
                 <c:pt idx="11" c:formatCode="0.0000">
-                  <c:v>1.0765</c:v>
+                  <c:v>1.0689</c:v>
                 </c:pt>
                 <c:pt idx="14" c:formatCode="0.0000">
-                  <c:v>1.6726</c:v>
+                  <c:v>1.7453</c:v>
                 </c:pt>
                 <c:pt idx="15" c:formatCode="0.0000">
-                  <c:v>1.259</c:v>
+                  <c:v>1.3262</c:v>
                 </c:pt>
                 <c:pt idx="17" c:formatCode="0.0000">
-                  <c:v>1.6101</c:v>
+                  <c:v>1.6695</c:v>
                 </c:pt>
                 <c:pt idx="18" c:formatCode="0.0000">
-                  <c:v>1.6624</c:v>
+                  <c:v>1.7258</c:v>
                 </c:pt>
               </c:numCache>
             </c:numRef>

</xml_diff>